<commit_message>
Add PDF export of Sodeystvie pitch v6, widen grant badges
Co-Authored-By: Claude Opus 5.5 <noreply@anthropic.com>
Claude-Session: https://claude.ai/code/session_01DZfKE2Qbh1BJBTBdA16C3f
</commit_message>
<xml_diff>
--- a/grant/Sodeystvie_pitch_v6.pptx
+++ b/grant/Sodeystvie_pitch_v6.pptx
@@ -7132,7 +7132,7 @@
         <p:spPr>
           <a:xfrm>
             <a:off x="6263640" y="2423160"/>
-            <a:ext cx="2103120" cy="548640"/>
+            <a:ext cx="2286000" cy="548640"/>
           </a:xfrm>
           <a:prstGeom prst="roundRect">
             <a:avLst>
@@ -7159,7 +7159,7 @@
         <p:spPr>
           <a:xfrm>
             <a:off x="6263640" y="2423160"/>
-            <a:ext cx="2103120" cy="548640"/>
+            <a:ext cx="2286000" cy="548640"/>
           </a:xfrm>
           <a:prstGeom prst="rect">
             <a:avLst/>
@@ -7197,8 +7197,8 @@
         </p:nvSpPr>
         <p:spPr>
           <a:xfrm>
-            <a:off x="8503920" y="2423160"/>
-            <a:ext cx="2103120" cy="548640"/>
+            <a:off x="8641080" y="2423160"/>
+            <a:ext cx="2286000" cy="548640"/>
           </a:xfrm>
           <a:prstGeom prst="roundRect">
             <a:avLst>
@@ -7224,8 +7224,8 @@
         </p:nvSpPr>
         <p:spPr>
           <a:xfrm>
-            <a:off x="8503920" y="2423160"/>
-            <a:ext cx="2103120" cy="548640"/>
+            <a:off x="8641080" y="2423160"/>
+            <a:ext cx="2286000" cy="548640"/>
           </a:xfrm>
           <a:prstGeom prst="rect">
             <a:avLst/>

</xml_diff>